<commit_message>
System Design vi: sd-14-020 deck updated for the signed-JWT scope
Co-Authored-By: Claude Sonnet 5.5 <noreply@anthropic.com>
Claude-Session: https://claude.ai/code/session_01WnjciXNJBLEd8jy3HrG49S
</commit_message>
<xml_diff>
--- a/system-design-101/vi/lessons/sd-14-020/slides/sd-14-020.pptx
+++ b/system-design-101/vi/lessons/sd-14-020/slides/sd-14-020.pptx
@@ -2695,6 +2695,28 @@
               </a:rPr>
               <a:t> JWT</a:t>
             </a:r>
+            <a:r>
+              <a:rPr lang="en-US" sz="1650" b="1" spc="212" kern="0" dirty="0">
+                <a:solidFill>
+                  <a:srgbClr val="9A98A0"/>
+                </a:solidFill>
+                <a:latin typeface="Be Vietnam Pro" pitchFamily="34" charset="0"/>
+                <a:ea typeface="Be Vietnam Pro" pitchFamily="34" charset="-122"/>
+                <a:cs typeface="Be Vietnam Pro" pitchFamily="34" charset="-120"/>
+              </a:rPr>
+              <a:t> DẠNG</a:t>
+            </a:r>
+            <a:r>
+              <a:rPr lang="en-US" sz="1650" b="1" spc="224" kern="0" dirty="0">
+                <a:solidFill>
+                  <a:srgbClr val="9A98A0"/>
+                </a:solidFill>
+                <a:latin typeface="Be Vietnam Pro" pitchFamily="34" charset="0"/>
+                <a:ea typeface="Be Vietnam Pro" pitchFamily="34" charset="-122"/>
+                <a:cs typeface="Be Vietnam Pro" pitchFamily="34" charset="-120"/>
+              </a:rPr>
+              <a:t> KÝ</a:t>
+            </a:r>
             <a:endParaRPr lang="en-US" sz="1650" dirty="0"/>
           </a:p>
         </p:txBody>
@@ -3866,7 +3888,7 @@
       </p:sp>
       <p:sp>
         <p:nvSpPr>
-          <p:cNvPr id="6" name="Connector line-1792334639533-642620684"/>
+          <p:cNvPr id="6" name="Connector line-1792337941650-437097555"/>
           <p:cNvSpPr/>
           <p:nvPr/>
         </p:nvSpPr>
@@ -4039,6 +4061,72 @@
               <a:t> chữ</a:t>
             </a:r>
             <a:r>
+              <a:rPr lang="en-US" sz="1800" dirty="0" spc="-2" kern="0">
+                <a:solidFill>
+                  <a:srgbClr val="D8D3C4"/>
+                </a:solidFill>
+                <a:latin typeface="Be Vietnam Pro" pitchFamily="34" charset="0"/>
+                <a:ea typeface="Be Vietnam Pro" pitchFamily="34" charset="-122"/>
+                <a:cs typeface="Be Vietnam Pro" pitchFamily="34" charset="-120"/>
+              </a:rPr>
+              <a:t> mang</a:t>
+            </a:r>
+            <a:r>
+              <a:rPr lang="en-US" sz="1800" dirty="0" spc="2" kern="0">
+                <a:solidFill>
+                  <a:srgbClr val="D8D3C4"/>
+                </a:solidFill>
+                <a:latin typeface="Be Vietnam Pro" pitchFamily="34" charset="0"/>
+                <a:ea typeface="Be Vietnam Pro" pitchFamily="34" charset="-122"/>
+                <a:cs typeface="Be Vietnam Pro" pitchFamily="34" charset="-120"/>
+              </a:rPr>
+              <a:t> các</a:t>
+            </a:r>
+            <a:r>
+              <a:rPr lang="en-US" sz="1800" dirty="0" spc="1" kern="0">
+                <a:solidFill>
+                  <a:srgbClr val="D8D3C4"/>
+                </a:solidFill>
+                <a:latin typeface="Be Vietnam Pro" pitchFamily="34" charset="0"/>
+                <a:ea typeface="Be Vietnam Pro" pitchFamily="34" charset="-122"/>
+                <a:cs typeface="Be Vietnam Pro" pitchFamily="34" charset="-120"/>
+              </a:rPr>
+              <a:t> claim</a:t>
+            </a:r>
+            <a:r>
+              <a:rPr lang="en-US" sz="1800" dirty="0" spc="-14" kern="0">
+                <a:solidFill>
+                  <a:srgbClr val="D8D3C4"/>
+                </a:solidFill>
+                <a:latin typeface="Be Vietnam Pro" pitchFamily="34" charset="0"/>
+                <a:ea typeface="Be Vietnam Pro" pitchFamily="34" charset="-122"/>
+                <a:cs typeface="Be Vietnam Pro" pitchFamily="34" charset="-120"/>
+              </a:rPr>
+              <a:t> về</a:t>
+            </a:r>
+            <a:r>
+              <a:rPr lang="en-US" sz="1800" dirty="0" spc="-7" kern="0">
+                <a:solidFill>
+                  <a:srgbClr val="D8D3C4"/>
+                </a:solidFill>
+                <a:latin typeface="Be Vietnam Pro" pitchFamily="34" charset="0"/>
+                <a:ea typeface="Be Vietnam Pro" pitchFamily="34" charset="-122"/>
+                <a:cs typeface="Be Vietnam Pro" pitchFamily="34" charset="-120"/>
+              </a:rPr>
+              <a:t> một</a:t>
+            </a:r>
+            <a:r>
+              <a:rPr lang="en-US" sz="1800" dirty="0" spc="2" kern="0">
+                <a:solidFill>
+                  <a:srgbClr val="D8D3C4"/>
+                </a:solidFill>
+                <a:latin typeface="Be Vietnam Pro" pitchFamily="34" charset="0"/>
+                <a:ea typeface="Be Vietnam Pro" pitchFamily="34" charset="-122"/>
+                <a:cs typeface="Be Vietnam Pro" pitchFamily="34" charset="-120"/>
+              </a:rPr>
+              <a:t> chủ</a:t>
+            </a:r>
+            <a:r>
               <a:rPr lang="en-US" sz="1800" dirty="0" spc="-1" kern="0">
                 <a:solidFill>
                   <a:srgbClr val="D8D3C4"/>
@@ -4047,51 +4135,7 @@
                 <a:ea typeface="Be Vietnam Pro" pitchFamily="34" charset="-122"/>
                 <a:cs typeface="Be Vietnam Pro" pitchFamily="34" charset="-120"/>
               </a:rPr>
-              <a:t> ba phần</a:t>
-            </a:r>
-            <a:r>
-              <a:rPr lang="en-US" sz="1800" dirty="0" spc="-2" kern="0">
-                <a:solidFill>
-                  <a:srgbClr val="D8D3C4"/>
-                </a:solidFill>
-                <a:latin typeface="Be Vietnam Pro" pitchFamily="34" charset="0"/>
-                <a:ea typeface="Be Vietnam Pro" pitchFamily="34" charset="-122"/>
-                <a:cs typeface="Be Vietnam Pro" pitchFamily="34" charset="-120"/>
-              </a:rPr>
-              <a:t> nối</a:t>
-            </a:r>
-            <a:r>
-              <a:rPr lang="en-US" sz="1800" dirty="0" spc="-4" kern="0">
-                <a:solidFill>
-                  <a:srgbClr val="D8D3C4"/>
-                </a:solidFill>
-                <a:latin typeface="Be Vietnam Pro" pitchFamily="34" charset="0"/>
-                <a:ea typeface="Be Vietnam Pro" pitchFamily="34" charset="-122"/>
-                <a:cs typeface="Be Vietnam Pro" pitchFamily="34" charset="-120"/>
-              </a:rPr>
-              <a:t> bằng</a:t>
-            </a:r>
-            <a:r>
-              <a:rPr lang="en-US" sz="1800" dirty="0" spc="-1" kern="0">
-                <a:solidFill>
-                  <a:srgbClr val="D8D3C4"/>
-                </a:solidFill>
-                <a:latin typeface="Be Vietnam Pro" pitchFamily="34" charset="0"/>
-                <a:ea typeface="Be Vietnam Pro" pitchFamily="34" charset="-122"/>
-                <a:cs typeface="Be Vietnam Pro" pitchFamily="34" charset="-120"/>
-              </a:rPr>
-              <a:t> dấu</a:t>
-            </a:r>
-            <a:r>
-              <a:rPr lang="en-US" sz="1800" dirty="0" spc="0" kern="0">
-                <a:solidFill>
-                  <a:srgbClr val="D8D3C4"/>
-                </a:solidFill>
-                <a:latin typeface="Be Vietnam Pro" pitchFamily="34" charset="0"/>
-                <a:ea typeface="Be Vietnam Pro" pitchFamily="34" charset="-122"/>
-                <a:cs typeface="Be Vietnam Pro" pitchFamily="34" charset="-120"/>
-              </a:rPr>
-              <a:t> chấm.</a:t>
+              <a:t> thể.</a:t>
             </a:r>
             <a:endParaRPr lang="en-US" sz="1800" dirty="0"/>
           </a:p>
@@ -4138,7 +4182,7 @@
           </a:solidFill>
           <a:ln w="28575">
             <a:solidFill>
-              <a:srgbClr val="9A98A0"/>
+              <a:srgbClr val="3DD6A0"/>
             </a:solidFill>
             <a:prstDash val="solid"/>
           </a:ln>
@@ -4146,7 +4190,7 @@
       </p:sp>
       <p:sp>
         <p:nvSpPr>
-          <p:cNvPr id="12" name="Connector line-1792334639541-527508169"/>
+          <p:cNvPr id="12" name="Connector line-1792337941659-702454031"/>
           <p:cNvSpPr/>
           <p:nvPr/>
         </p:nvSpPr>
@@ -4161,7 +4205,7 @@
           <a:noFill/>
           <a:ln w="28575">
             <a:solidFill>
-              <a:srgbClr val="9A98A0"/>
+              <a:srgbClr val="3DD6A0"/>
             </a:solidFill>
             <a:prstDash val="solid"/>
             <a:headEnd type="none"/>
@@ -4194,15 +4238,15 @@
               <a:buNone/>
             </a:pPr>
             <a:r>
-              <a:rPr lang="en-US" sz="3900" dirty="0" spc="-3" kern="0">
-                <a:solidFill>
-                  <a:srgbClr val="F3EEE3"/>
+              <a:rPr lang="en-US" sz="3900" dirty="0" spc="-13" kern="0">
+                <a:solidFill>
+                  <a:srgbClr val="3DD6A0"/>
                 </a:solidFill>
                 <a:latin typeface="Bricolage Grotesque ExtraBold" pitchFamily="34" charset="0"/>
                 <a:ea typeface="Bricolage Grotesque ExtraBold" pitchFamily="34" charset="-122"/>
                 <a:cs typeface="Bricolage Grotesque ExtraBold" pitchFamily="34" charset="-120"/>
               </a:rPr>
-              <a:t>JSON</a:t>
+              <a:t>JWS</a:t>
             </a:r>
             <a:endParaRPr lang="en-US" sz="3900" dirty="0"/>
           </a:p>
@@ -4233,7 +4277,7 @@
               <a:buNone/>
             </a:pPr>
             <a:r>
-              <a:rPr lang="en-US" sz="1650" dirty="0" spc="-5" kern="0">
+              <a:rPr lang="en-US" sz="1650" dirty="0" spc="6" kern="0">
                 <a:solidFill>
                   <a:srgbClr val="9A98A0"/>
                 </a:solidFill>
@@ -4241,10 +4285,10 @@
                 <a:ea typeface="Be Vietnam Pro" pitchFamily="34" charset="-122"/>
                 <a:cs typeface="Be Vietnam Pro" pitchFamily="34" charset="-120"/>
               </a:rPr>
-              <a:t>JavaScript</a:t>
-            </a:r>
-            <a:r>
-              <a:rPr lang="en-US" sz="1650" dirty="0" spc="-9" kern="0">
+              <a:t>JSON</a:t>
+            </a:r>
+            <a:r>
+              <a:rPr lang="en-US" sz="1650" dirty="0" spc="-18" kern="0">
                 <a:solidFill>
                   <a:srgbClr val="9A98A0"/>
                 </a:solidFill>
@@ -4252,10 +4296,10 @@
                 <a:ea typeface="Be Vietnam Pro" pitchFamily="34" charset="-122"/>
                 <a:cs typeface="Be Vietnam Pro" pitchFamily="34" charset="-120"/>
               </a:rPr>
-              <a:t> Object</a:t>
-            </a:r>
-            <a:r>
-              <a:rPr lang="en-US" sz="1650" dirty="0" spc="-10" kern="0">
+              <a:t> Web</a:t>
+            </a:r>
+            <a:r>
+              <a:rPr lang="en-US" sz="1650" dirty="0" spc="-11" kern="0">
                 <a:solidFill>
                   <a:srgbClr val="9A98A0"/>
                 </a:solidFill>
@@ -4263,7 +4307,7 @@
                 <a:ea typeface="Be Vietnam Pro" pitchFamily="34" charset="-122"/>
                 <a:cs typeface="Be Vietnam Pro" pitchFamily="34" charset="-120"/>
               </a:rPr>
-              <a:t> Notation</a:t>
+              <a:t> Signature</a:t>
             </a:r>
             <a:endParaRPr lang="en-US" sz="1650" dirty="0"/>
           </a:p>
@@ -4297,6 +4341,28 @@
               <a:buNone/>
             </a:pPr>
             <a:r>
+              <a:rPr lang="en-US" sz="1800" dirty="0" spc="-3" kern="0">
+                <a:solidFill>
+                  <a:srgbClr val="D8D3C4"/>
+                </a:solidFill>
+                <a:latin typeface="Be Vietnam Pro" pitchFamily="34" charset="0"/>
+                <a:ea typeface="Be Vietnam Pro" pitchFamily="34" charset="-122"/>
+                <a:cs typeface="Be Vietnam Pro" pitchFamily="34" charset="-120"/>
+              </a:rPr>
+              <a:t>dạng</a:t>
+            </a:r>
+            <a:r>
+              <a:rPr lang="en-US" sz="1800" dirty="0" spc="7" kern="0">
+                <a:solidFill>
+                  <a:srgbClr val="D8D3C4"/>
+                </a:solidFill>
+                <a:latin typeface="Be Vietnam Pro" pitchFamily="34" charset="0"/>
+                <a:ea typeface="Be Vietnam Pro" pitchFamily="34" charset="-122"/>
+                <a:cs typeface="Be Vietnam Pro" pitchFamily="34" charset="-120"/>
+              </a:rPr>
+              <a:t> JWT được</a:t>
+            </a:r>
+            <a:r>
               <a:rPr lang="en-US" sz="1800" dirty="0" spc="-1" kern="0">
                 <a:solidFill>
                   <a:srgbClr val="D8D3C4"/>
@@ -4305,10 +4371,10 @@
                 <a:ea typeface="Be Vietnam Pro" pitchFamily="34" charset="-122"/>
                 <a:cs typeface="Be Vietnam Pro" pitchFamily="34" charset="-120"/>
               </a:rPr>
-              <a:t>Ghi</a:t>
-            </a:r>
-            <a:r>
-              <a:rPr lang="en-US" sz="1800" dirty="0" spc="0" kern="0">
+              <a:t> ký,</a:t>
+            </a:r>
+            <a:r>
+              <a:rPr lang="en-US" sz="1800" dirty="0" spc="-2" kern="0">
                 <a:solidFill>
                   <a:srgbClr val="D8D3C4"/>
                 </a:solidFill>
@@ -4316,10 +4382,10 @@
                 <a:ea typeface="Be Vietnam Pro" pitchFamily="34" charset="-122"/>
                 <a:cs typeface="Be Vietnam Pro" pitchFamily="34" charset="-120"/>
               </a:rPr>
-              <a:t> dữ</a:t>
-            </a:r>
-            <a:r>
-              <a:rPr lang="en-US" sz="1800" dirty="0" spc="-2" kern="0">
+              <a:t> không mã</a:t>
+            </a:r>
+            <a:r>
+              <a:rPr lang="en-US" sz="1800" dirty="0" spc="-1" kern="0">
                 <a:solidFill>
                   <a:srgbClr val="D8D3C4"/>
                 </a:solidFill>
@@ -4327,51 +4393,7 @@
                 <a:ea typeface="Be Vietnam Pro" pitchFamily="34" charset="-122"/>
                 <a:cs typeface="Be Vietnam Pro" pitchFamily="34" charset="-120"/>
               </a:rPr>
-              <a:t> liệu thành</a:t>
-            </a:r>
-            <a:r>
-              <a:rPr lang="en-US" sz="1800" dirty="0" spc="1" kern="0">
-                <a:solidFill>
-                  <a:srgbClr val="D8D3C4"/>
-                </a:solidFill>
-                <a:latin typeface="Be Vietnam Pro" pitchFamily="34" charset="0"/>
-                <a:ea typeface="Be Vietnam Pro" pitchFamily="34" charset="-122"/>
-                <a:cs typeface="Be Vietnam Pro" pitchFamily="34" charset="-120"/>
-              </a:rPr>
-              <a:t> cặp</a:t>
-            </a:r>
-            <a:r>
-              <a:rPr lang="en-US" sz="1800" dirty="0" spc="-12" kern="0">
-                <a:solidFill>
-                  <a:srgbClr val="D8D3C4"/>
-                </a:solidFill>
-                <a:latin typeface="Be Vietnam Pro" pitchFamily="34" charset="0"/>
-                <a:ea typeface="Be Vietnam Pro" pitchFamily="34" charset="-122"/>
-                <a:cs typeface="Be Vietnam Pro" pitchFamily="34" charset="-120"/>
-              </a:rPr>
-              <a:t> tên và</a:t>
-            </a:r>
-            <a:r>
-              <a:rPr lang="en-US" sz="1800" dirty="0" spc="0" kern="0">
-                <a:solidFill>
-                  <a:srgbClr val="D8D3C4"/>
-                </a:solidFill>
-                <a:latin typeface="Be Vietnam Pro" pitchFamily="34" charset="0"/>
-                <a:ea typeface="Be Vietnam Pro" pitchFamily="34" charset="-122"/>
-                <a:cs typeface="Be Vietnam Pro" pitchFamily="34" charset="-120"/>
-              </a:rPr>
-              <a:t> giá</a:t>
-            </a:r>
-            <a:r>
-              <a:rPr lang="en-US" sz="1800" dirty="0" spc="7" kern="0">
-                <a:solidFill>
-                  <a:srgbClr val="D8D3C4"/>
-                </a:solidFill>
-                <a:latin typeface="Be Vietnam Pro" pitchFamily="34" charset="0"/>
-                <a:ea typeface="Be Vietnam Pro" pitchFamily="34" charset="-122"/>
-                <a:cs typeface="Be Vietnam Pro" pitchFamily="34" charset="-120"/>
-              </a:rPr>
-              <a:t> trị.</a:t>
+              <a:t> hóa</a:t>
             </a:r>
             <a:endParaRPr lang="en-US" sz="1800" dirty="0"/>
           </a:p>
@@ -4426,7 +4448,7 @@
       </p:sp>
       <p:sp>
         <p:nvSpPr>
-          <p:cNvPr id="18" name="Connector line-1792334639548-91918641"/>
+          <p:cNvPr id="18" name="Connector line-1792337941665-527907506"/>
           <p:cNvSpPr/>
           <p:nvPr/>
         </p:nvSpPr>
@@ -4728,7 +4750,7 @@
       </p:sp>
       <p:sp>
         <p:nvSpPr>
-          <p:cNvPr id="24" name="Connector line-1792334639555-819167446"/>
+          <p:cNvPr id="24" name="Connector line-1792337941671-534532566"/>
           <p:cNvSpPr/>
           <p:nvPr/>
         </p:nvSpPr>
@@ -5019,7 +5041,7 @@
       </p:sp>
       <p:sp>
         <p:nvSpPr>
-          <p:cNvPr id="30" name="Connector line-1792334639562-530265973"/>
+          <p:cNvPr id="30" name="Connector line-1792337941678-711601852"/>
           <p:cNvSpPr/>
           <p:nvPr/>
         </p:nvSpPr>
@@ -5244,7 +5266,7 @@
       </p:sp>
       <p:sp>
         <p:nvSpPr>
-          <p:cNvPr id="36" name="Connector line-1792334639567-250634688"/>
+          <p:cNvPr id="36" name="Connector line-1792337941682-985762907"/>
           <p:cNvSpPr/>
           <p:nvPr/>
         </p:nvSpPr>
@@ -5568,7 +5590,7 @@
       </p:sp>
       <p:sp>
         <p:nvSpPr>
-          <p:cNvPr id="42" name="Connector line-1792334639573-119378303"/>
+          <p:cNvPr id="42" name="Connector line-1792337941687-17608542"/>
           <p:cNvSpPr/>
           <p:nvPr/>
         </p:nvSpPr>
@@ -5727,10 +5749,10 @@
                 <a:ea typeface="Be Vietnam Pro" pitchFamily="34" charset="-122"/>
                 <a:cs typeface="Be Vietnam Pro" pitchFamily="34" charset="-120"/>
               </a:rPr>
-              <a:t>Dạng</a:t>
-            </a:r>
-            <a:r>
-              <a:rPr lang="en-US" sz="1800" dirty="0" spc="-20" kern="0">
+              <a:t>dạng</a:t>
+            </a:r>
+            <a:r>
+              <a:rPr lang="en-US" sz="1800" dirty="0" spc="7" kern="0">
                 <a:solidFill>
                   <a:srgbClr val="D8D3C4"/>
                 </a:solidFill>
@@ -5738,10 +5760,10 @@
                 <a:ea typeface="Be Vietnam Pro" pitchFamily="34" charset="-122"/>
                 <a:cs typeface="Be Vietnam Pro" pitchFamily="34" charset="-120"/>
               </a:rPr>
-              <a:t> token</a:t>
-            </a:r>
-            <a:r>
-              <a:rPr lang="en-US" sz="1800" dirty="0" spc="1" kern="0">
+              <a:t> JWT</a:t>
+            </a:r>
+            <a:r>
+              <a:rPr lang="en-US" sz="1800" dirty="0" spc="-1" kern="0">
                 <a:solidFill>
                   <a:srgbClr val="D8D3C4"/>
                 </a:solidFill>
@@ -5749,10 +5771,10 @@
                 <a:ea typeface="Be Vietnam Pro" pitchFamily="34" charset="-122"/>
                 <a:cs typeface="Be Vietnam Pro" pitchFamily="34" charset="-120"/>
               </a:rPr>
-              <a:t> có</a:t>
-            </a:r>
-            <a:r>
-              <a:rPr lang="en-US" sz="1800" dirty="0" spc="-4" kern="0">
+              <a:t> mã</a:t>
+            </a:r>
+            <a:r>
+              <a:rPr lang="en-US" sz="1800" dirty="0" spc="-2" kern="0">
                 <a:solidFill>
                   <a:srgbClr val="D8D3C4"/>
                 </a:solidFill>
@@ -5760,10 +5782,10 @@
                 <a:ea typeface="Be Vietnam Pro" pitchFamily="34" charset="-122"/>
                 <a:cs typeface="Be Vietnam Pro" pitchFamily="34" charset="-120"/>
               </a:rPr>
-              <a:t> payload</a:t>
-            </a:r>
-            <a:r>
-              <a:rPr lang="en-US" sz="1800" dirty="0" spc="7" kern="0">
+              <a:t> hóa,</a:t>
+            </a:r>
+            <a:r>
+              <a:rPr lang="en-US" sz="1800" dirty="0" spc="0" kern="0">
                 <a:solidFill>
                   <a:srgbClr val="D8D3C4"/>
                 </a:solidFill>
@@ -5771,10 +5793,10 @@
                 <a:ea typeface="Be Vietnam Pro" pitchFamily="34" charset="-122"/>
                 <a:cs typeface="Be Vietnam Pro" pitchFamily="34" charset="-120"/>
               </a:rPr>
-              <a:t> được</a:t>
-            </a:r>
-            <a:r>
-              <a:rPr lang="en-US" sz="1800" dirty="0" spc="-2" kern="0">
+              <a:t> cấu</a:t>
+            </a:r>
+            <a:r>
+              <a:rPr lang="en-US" sz="1800" dirty="0" spc="2" kern="0">
                 <a:solidFill>
                   <a:srgbClr val="D8D3C4"/>
                 </a:solidFill>
@@ -5782,7 +5804,7 @@
                 <a:ea typeface="Be Vietnam Pro" pitchFamily="34" charset="-122"/>
                 <a:cs typeface="Be Vietnam Pro" pitchFamily="34" charset="-120"/>
               </a:rPr>
-              <a:t> mã</a:t>
+              <a:t> trúc</a:t>
             </a:r>
             <a:r>
               <a:rPr lang="en-US" sz="1800" dirty="0" spc="0" kern="0">
@@ -5793,7 +5815,7 @@
                 <a:ea typeface="Be Vietnam Pro" pitchFamily="34" charset="-122"/>
                 <a:cs typeface="Be Vietnam Pro" pitchFamily="34" charset="-120"/>
               </a:rPr>
-              <a:t> hóa.</a:t>
+              <a:t> khác</a:t>
             </a:r>
             <a:endParaRPr lang="en-US" sz="1800" dirty="0"/>
           </a:p>
@@ -5848,7 +5870,7 @@
       </p:sp>
       <p:sp>
         <p:nvSpPr>
-          <p:cNvPr id="48" name="Connector line-1792334639579-309930675"/>
+          <p:cNvPr id="48" name="Connector line-1792337941693-310185199"/>
           <p:cNvSpPr/>
           <p:nvPr/>
         </p:nvSpPr>
@@ -6495,7 +6517,7 @@
       </p:sp>
       <p:sp>
         <p:nvSpPr>
-          <p:cNvPr id="55" name="Connector line-1792334639591-260985818"/>
+          <p:cNvPr id="55" name="Connector line-1792337941703-700982757"/>
           <p:cNvSpPr/>
           <p:nvPr/>
         </p:nvSpPr>
@@ -7206,7 +7228,7 @@
               <a:t>Một</a:t>
             </a:r>
             <a:r>
-              <a:rPr lang="en-US" sz="2700" dirty="0" spc="-29" kern="0">
+              <a:rPr lang="en-US" sz="2700" dirty="0" spc="16" kern="0">
                 <a:solidFill>
                   <a:srgbClr val="14161C"/>
                 </a:solidFill>
@@ -7214,7 +7236,7 @@
                 <a:ea typeface="Be Vietnam Pro" pitchFamily="34" charset="-122"/>
                 <a:cs typeface="Be Vietnam Pro" pitchFamily="34" charset="-120"/>
               </a:rPr>
-              <a:t> token</a:t>
+              <a:t> JWT</a:t>
             </a:r>
             <a:r>
               <a:rPr lang="en-US" sz="2700" dirty="0" spc="-2" kern="0">
@@ -7225,21 +7247,43 @@
                 <a:ea typeface="Be Vietnam Pro" pitchFamily="34" charset="-122"/>
                 <a:cs typeface="Be Vietnam Pro" pitchFamily="34" charset="-120"/>
               </a:rPr>
+              <a:t> dạng</a:t>
+            </a:r>
+            <a:r>
+              <a:rPr lang="en-US" sz="2700" dirty="0" spc="-3" kern="0">
+                <a:solidFill>
+                  <a:srgbClr val="14161C"/>
+                </a:solidFill>
+                <a:latin typeface="Be Vietnam Pro" pitchFamily="34" charset="0"/>
+                <a:ea typeface="Be Vietnam Pro" pitchFamily="34" charset="-122"/>
+                <a:cs typeface="Be Vietnam Pro" pitchFamily="34" charset="-120"/>
+              </a:rPr>
+              <a:t> ký</a:t>
+            </a:r>
+            <a:r>
+              <a:rPr lang="en-US" sz="2700" dirty="0" spc="-1" kern="0">
+                <a:solidFill>
+                  <a:srgbClr val="14161C"/>
+                </a:solidFill>
+                <a:latin typeface="Be Vietnam Pro" pitchFamily="34" charset="0"/>
+                <a:ea typeface="Be Vietnam Pro" pitchFamily="34" charset="-122"/>
+                <a:cs typeface="Be Vietnam Pro" pitchFamily="34" charset="-120"/>
+              </a:rPr>
               <a:t> là</a:t>
             </a:r>
             <a:r>
+              <a:rPr lang="en-US" sz="2700" dirty="0" spc="1" kern="0">
+                <a:solidFill>
+                  <a:srgbClr val="14161C"/>
+                </a:solidFill>
+                <a:latin typeface="Be Vietnam Pro" pitchFamily="34" charset="0"/>
+                <a:ea typeface="Be Vietnam Pro" pitchFamily="34" charset="-122"/>
+                <a:cs typeface="Be Vietnam Pro" pitchFamily="34" charset="-120"/>
+              </a:rPr>
+              <a:t> chuỗi</a:t>
+            </a:r>
+            <a:r>
               <a:rPr lang="en-US" sz="2700" dirty="0" spc="0" kern="0">
-                <a:solidFill>
-                  <a:srgbClr val="14161C"/>
-                </a:solidFill>
-                <a:latin typeface="Be Vietnam Pro" pitchFamily="34" charset="0"/>
-                <a:ea typeface="Be Vietnam Pro" pitchFamily="34" charset="-122"/>
-                <a:cs typeface="Be Vietnam Pro" pitchFamily="34" charset="-120"/>
-              </a:rPr>
-              <a:t> chuỗi</a:t>
-            </a:r>
-            <a:r>
-              <a:rPr lang="en-US" sz="2700" dirty="0" spc="1" kern="0">
                 <a:solidFill>
                   <a:srgbClr val="14161C"/>
                 </a:solidFill>
@@ -8907,7 +8951,7 @@
         <p:spPr>
           <a:xfrm>
             <a:off x="914400" y="1333500"/>
-            <a:ext cx="16459200" cy="1428750"/>
+            <a:ext cx="16459200" cy="1238250"/>
           </a:xfrm>
           <a:prstGeom prst="rect">
             <a:avLst/>
@@ -8916,17 +8960,17 @@
           <a:ln/>
         </p:spPr>
         <p:txBody>
-          <a:bodyPr wrap="square" lIns="0" tIns="64294" rIns="0" bIns="-64294" rtlCol="0" anchor="t"/>
+          <a:bodyPr wrap="square" lIns="0" tIns="59150" rIns="0" bIns="-59150" rtlCol="0" anchor="t"/>
           <a:lstStyle/>
           <a:p>
             <a:pPr algn="l" indent="0" marL="0">
               <a:lnSpc>
-                <a:spcPts val="7875"/>
+                <a:spcPts val="7245"/>
               </a:lnSpc>
               <a:buNone/>
             </a:pPr>
             <a:r>
-              <a:rPr lang="en-US" sz="7500" dirty="0" spc="-2" kern="0">
+              <a:rPr lang="en-US" sz="6900" dirty="0" spc="22" kern="0">
                 <a:solidFill>
                   <a:srgbClr val="14161C"/>
                 </a:solidFill>
@@ -8934,10 +8978,10 @@
                 <a:ea typeface="Bricolage Grotesque ExtraBold" pitchFamily="34" charset="-122"/>
                 <a:cs typeface="Bricolage Grotesque ExtraBold" pitchFamily="34" charset="-120"/>
               </a:rPr>
-              <a:t>Ba</a:t>
-            </a:r>
-            <a:r>
-              <a:rPr lang="en-US" sz="7500" dirty="0" spc="4" kern="0">
+              <a:t>JWT</a:t>
+            </a:r>
+            <a:r>
+              <a:rPr lang="en-US" sz="6900" dirty="0" spc="0" kern="0">
                 <a:solidFill>
                   <a:srgbClr val="14161C"/>
                 </a:solidFill>
@@ -8945,10 +8989,10 @@
                 <a:ea typeface="Bricolage Grotesque ExtraBold" pitchFamily="34" charset="-122"/>
                 <a:cs typeface="Bricolage Grotesque ExtraBold" pitchFamily="34" charset="-120"/>
               </a:rPr>
-              <a:t> phần</a:t>
-            </a:r>
-            <a:r>
-              <a:rPr lang="en-US" sz="7500" dirty="0" spc="2" kern="0">
+              <a:t> dạng</a:t>
+            </a:r>
+            <a:r>
+              <a:rPr lang="en-US" sz="6900" dirty="0" spc="1" kern="0">
                 <a:solidFill>
                   <a:srgbClr val="14161C"/>
                 </a:solidFill>
@@ -8956,10 +9000,10 @@
                 <a:ea typeface="Bricolage Grotesque ExtraBold" pitchFamily="34" charset="-122"/>
                 <a:cs typeface="Bricolage Grotesque ExtraBold" pitchFamily="34" charset="-120"/>
               </a:rPr>
-              <a:t> nối</a:t>
-            </a:r>
-            <a:r>
-              <a:rPr lang="en-US" sz="7500" dirty="0" spc="-4" kern="0">
+              <a:t> ký:</a:t>
+            </a:r>
+            <a:r>
+              <a:rPr lang="en-US" sz="6900" dirty="0" spc="-6" kern="0">
                 <a:solidFill>
                   <a:srgbClr val="14161C"/>
                 </a:solidFill>
@@ -8967,10 +9011,10 @@
                 <a:ea typeface="Bricolage Grotesque ExtraBold" pitchFamily="34" charset="-122"/>
                 <a:cs typeface="Bricolage Grotesque ExtraBold" pitchFamily="34" charset="-120"/>
               </a:rPr>
-              <a:t> bằng</a:t>
-            </a:r>
-            <a:r>
-              <a:rPr lang="en-US" sz="7500" dirty="0" spc="-2" kern="0">
+              <a:t> ba</a:t>
+            </a:r>
+            <a:r>
+              <a:rPr lang="en-US" sz="6900" dirty="0" spc="3" kern="0">
                 <a:solidFill>
                   <a:srgbClr val="14161C"/>
                 </a:solidFill>
@@ -8978,10 +9022,10 @@
                 <a:ea typeface="Bricolage Grotesque ExtraBold" pitchFamily="34" charset="-122"/>
                 <a:cs typeface="Bricolage Grotesque ExtraBold" pitchFamily="34" charset="-120"/>
               </a:rPr>
-              <a:t> dấu</a:t>
-            </a:r>
-            <a:r>
-              <a:rPr lang="en-US" sz="7500" dirty="0" spc="1" kern="0">
+              <a:t> phần</a:t>
+            </a:r>
+            <a:r>
+              <a:rPr lang="en-US" sz="6900" dirty="0" spc="1" kern="0">
                 <a:solidFill>
                   <a:srgbClr val="14161C"/>
                 </a:solidFill>
@@ -8989,9 +9033,42 @@
                 <a:ea typeface="Bricolage Grotesque ExtraBold" pitchFamily="34" charset="-122"/>
                 <a:cs typeface="Bricolage Grotesque ExtraBold" pitchFamily="34" charset="-120"/>
               </a:rPr>
+              <a:t> nối</a:t>
+            </a:r>
+            <a:r>
+              <a:rPr lang="en-US" sz="6900" dirty="0" spc="-2" kern="0">
+                <a:solidFill>
+                  <a:srgbClr val="14161C"/>
+                </a:solidFill>
+                <a:latin typeface="Bricolage Grotesque ExtraBold" pitchFamily="34" charset="0"/>
+                <a:ea typeface="Bricolage Grotesque ExtraBold" pitchFamily="34" charset="-122"/>
+                <a:cs typeface="Bricolage Grotesque ExtraBold" pitchFamily="34" charset="-120"/>
+              </a:rPr>
+              <a:t> bằng</a:t>
+            </a:r>
+            <a:r>
+              <a:rPr lang="en-US" sz="6900" dirty="0" spc="0" kern="0">
+                <a:solidFill>
+                  <a:srgbClr val="14161C"/>
+                </a:solidFill>
+                <a:latin typeface="Bricolage Grotesque ExtraBold" pitchFamily="34" charset="0"/>
+                <a:ea typeface="Bricolage Grotesque ExtraBold" pitchFamily="34" charset="-122"/>
+                <a:cs typeface="Bricolage Grotesque ExtraBold" pitchFamily="34" charset="-120"/>
+              </a:rPr>
+              <a:t> dấu</a:t>
+            </a:r>
+            <a:r>
+              <a:rPr lang="en-US" sz="6900" dirty="0" spc="-2" kern="0">
+                <a:solidFill>
+                  <a:srgbClr val="14161C"/>
+                </a:solidFill>
+                <a:latin typeface="Bricolage Grotesque ExtraBold" pitchFamily="34" charset="0"/>
+                <a:ea typeface="Bricolage Grotesque ExtraBold" pitchFamily="34" charset="-122"/>
+                <a:cs typeface="Bricolage Grotesque ExtraBold" pitchFamily="34" charset="-120"/>
+              </a:rPr>
               <a:t> chấm</a:t>
             </a:r>
-            <a:endParaRPr lang="en-US" sz="7500" dirty="0"/>
+            <a:endParaRPr lang="en-US" sz="6900" dirty="0"/>
           </a:p>
         </p:txBody>
       </p:sp>
@@ -20140,7 +20217,7 @@
       </p:sp>
       <p:sp>
         <p:nvSpPr>
-          <p:cNvPr id="6" name="Connector line-1792334537293-955975268"/>
+          <p:cNvPr id="6" name="Connector line-1792337919329-461996490"/>
           <p:cNvSpPr/>
           <p:nvPr/>
         </p:nvSpPr>
@@ -20237,7 +20314,7 @@
       </p:sp>
       <p:sp>
         <p:nvSpPr>
-          <p:cNvPr id="8" name="Text richtext-1792334537298-84067338"/>
+          <p:cNvPr id="8" name="Text richtext-1792337919332-799757048"/>
           <p:cNvSpPr/>
           <p:nvPr/>
         </p:nvSpPr>
@@ -20474,7 +20551,7 @@
       </p:sp>
       <p:sp>
         <p:nvSpPr>
-          <p:cNvPr id="11" name="Connector line-1792334537321-714628464"/>
+          <p:cNvPr id="11" name="Connector line-1792337919350-264910377"/>
           <p:cNvSpPr/>
           <p:nvPr/>
         </p:nvSpPr>
@@ -20571,7 +20648,7 @@
       </p:sp>
       <p:sp>
         <p:nvSpPr>
-          <p:cNvPr id="13" name="Text richtext-1792334537323-449620004"/>
+          <p:cNvPr id="13" name="Text richtext-1792337919353-41439967"/>
           <p:cNvSpPr/>
           <p:nvPr/>
         </p:nvSpPr>
@@ -20610,7 +20687,7 @@
                 <a:ea typeface="Be Vietnam Pro" pitchFamily="34" charset="-122"/>
                 <a:cs typeface="Be Vietnam Pro" pitchFamily="34" charset="-120"/>
               </a:rPr>
-              <a:t>Không</a:t>
+              <a:t>Dạng</a:t>
             </a:r>
             <a:r>
               <a:rPr lang="en-US" sz="2550" dirty="0" spc="1" kern="0">
@@ -20621,7 +20698,40 @@
                 <a:ea typeface="Be Vietnam Pro" pitchFamily="34" charset="-122"/>
                 <a:cs typeface="Be Vietnam Pro" pitchFamily="34" charset="-120"/>
               </a:rPr>
-              <a:t> giấu</a:t>
+              <a:t> ký</a:t>
+            </a:r>
+            <a:r>
+              <a:rPr lang="en-US" sz="2550" dirty="0" spc="0" kern="0">
+                <a:solidFill>
+                  <a:srgbClr val="F3EEE3"/>
+                </a:solidFill>
+                <a:latin typeface="Be Vietnam Pro" pitchFamily="34" charset="0"/>
+                <a:ea typeface="Be Vietnam Pro" pitchFamily="34" charset="-122"/>
+                <a:cs typeface="Be Vietnam Pro" pitchFamily="34" charset="-120"/>
+              </a:rPr>
+              <a:t> không</a:t>
+            </a:r>
+            <a:r>
+              <a:rPr lang="en-US" sz="2550" dirty="0" spc="2" kern="0">
+                <a:solidFill>
+                  <a:srgbClr val="F3EEE3"/>
+                </a:solidFill>
+                <a:latin typeface="Be Vietnam Pro" pitchFamily="34" charset="0"/>
+                <a:ea typeface="Be Vietnam Pro" pitchFamily="34" charset="-122"/>
+                <a:cs typeface="Be Vietnam Pro" pitchFamily="34" charset="-120"/>
+              </a:rPr>
+              <a:t> mã</a:t>
+            </a:r>
+            <a:r>
+              <a:rPr lang="en-US" sz="2550" dirty="0" spc="-4" kern="0">
+                <a:solidFill>
+                  <a:srgbClr val="F3EEE3"/>
+                </a:solidFill>
+                <a:latin typeface="Be Vietnam Pro" pitchFamily="34" charset="0"/>
+                <a:ea typeface="Be Vietnam Pro" pitchFamily="34" charset="-122"/>
+                <a:cs typeface="Be Vietnam Pro" pitchFamily="34" charset="-120"/>
+              </a:rPr>
+              <a:t> hóa</a:t>
             </a:r>
             <a:r>
               <a:rPr lang="en-US" sz="2550" dirty="0" spc="-8" kern="0">
@@ -20786,7 +20896,7 @@
       </p:sp>
       <p:sp>
         <p:nvSpPr>
-          <p:cNvPr id="16" name="Connector line-1792334537330-318318221"/>
+          <p:cNvPr id="16" name="Connector line-1792337919360-669410829"/>
           <p:cNvSpPr/>
           <p:nvPr/>
         </p:nvSpPr>
@@ -21045,7 +21155,7 @@
       </p:sp>
       <p:sp>
         <p:nvSpPr>
-          <p:cNvPr id="20" name="Connector line-1792334537337-417356765"/>
+          <p:cNvPr id="20" name="Connector line-1792337919368-471947033"/>
           <p:cNvSpPr/>
           <p:nvPr/>
         </p:nvSpPr>
@@ -21070,7 +21180,7 @@
       </p:sp>
       <p:sp>
         <p:nvSpPr>
-          <p:cNvPr id="21" name="Connector line-1792334537338-707370746"/>
+          <p:cNvPr id="21" name="Connector line-1792337919368-51346378"/>
           <p:cNvSpPr/>
           <p:nvPr/>
         </p:nvSpPr>
@@ -21095,7 +21205,7 @@
       </p:sp>
       <p:sp>
         <p:nvSpPr>
-          <p:cNvPr id="22" name="Connector line-1792334537338-620879962"/>
+          <p:cNvPr id="22" name="Connector line-1792337919368-135557334"/>
           <p:cNvSpPr/>
           <p:nvPr/>
         </p:nvSpPr>
@@ -21369,7 +21479,7 @@
         </p:nvSpPr>
         <p:spPr>
           <a:xfrm>
-            <a:off x="9334500" y="6953250"/>
+            <a:off x="9334500" y="6810375"/>
             <a:ext cx="7658100" cy="952500"/>
           </a:xfrm>
           <a:prstGeom prst="roundRect">
@@ -21489,8 +21599,8 @@
         </p:nvSpPr>
         <p:spPr>
           <a:xfrm>
-            <a:off x="9334500" y="8143875"/>
-            <a:ext cx="7658100" cy="381000"/>
+            <a:off x="9334500" y="7953375"/>
+            <a:ext cx="7658100" cy="800100"/>
           </a:xfrm>
           <a:prstGeom prst="rect">
             <a:avLst/>
@@ -21499,10 +21609,13 @@
           <a:ln/>
         </p:spPr>
         <p:txBody>
-          <a:bodyPr wrap="square" lIns="0" tIns="0" rIns="0" bIns="0" rtlCol="0" anchor="t"/>
+          <a:bodyPr wrap="square" lIns="0" tIns="11335" rIns="0" bIns="-11335" rtlCol="0" anchor="t"/>
           <a:lstStyle/>
           <a:p>
             <a:pPr algn="l" indent="0" marL="0">
+              <a:lnSpc>
+                <a:spcPts val="2730"/>
+              </a:lnSpc>
               <a:buNone/>
             </a:pPr>
             <a:r>
@@ -21539,7 +21652,7 @@
               <a:t> kín:</a:t>
             </a:r>
             <a:r>
-              <a:rPr lang="en-US" sz="2100" dirty="0" spc="7" kern="0">
+              <a:rPr lang="en-US" sz="2100" dirty="0" spc="-1" kern="0">
                 <a:solidFill>
                   <a:srgbClr val="D8D3C4"/>
                 </a:solidFill>
@@ -21547,7 +21660,106 @@
                 <a:ea typeface="Be Vietnam Pro" pitchFamily="34" charset="-122"/>
                 <a:cs typeface="Be Vietnam Pro" pitchFamily="34" charset="-120"/>
               </a:rPr>
-              <a:t> JWE,</a:t>
+              <a:t> dùng</a:t>
+            </a:r>
+            <a:r>
+              <a:rPr lang="en-US" sz="2100" dirty="0" spc="10" kern="0">
+                <a:solidFill>
+                  <a:srgbClr val="D8D3C4"/>
+                </a:solidFill>
+                <a:latin typeface="Be Vietnam Pro" pitchFamily="34" charset="0"/>
+                <a:ea typeface="Be Vietnam Pro" pitchFamily="34" charset="-122"/>
+                <a:cs typeface="Be Vietnam Pro" pitchFamily="34" charset="-120"/>
+              </a:rPr>
+              <a:t> JWT</a:t>
+            </a:r>
+            <a:r>
+              <a:rPr lang="en-US" sz="2100" dirty="0" spc="-3" kern="0">
+                <a:solidFill>
+                  <a:srgbClr val="D8D3C4"/>
+                </a:solidFill>
+                <a:latin typeface="Be Vietnam Pro" pitchFamily="34" charset="0"/>
+                <a:ea typeface="Be Vietnam Pro" pitchFamily="34" charset="-122"/>
+                <a:cs typeface="Be Vietnam Pro" pitchFamily="34" charset="-120"/>
+              </a:rPr>
+              <a:t> mã</a:t>
+            </a:r>
+            <a:r>
+              <a:rPr lang="en-US" sz="2100" dirty="0" spc="-6" kern="0">
+                <a:solidFill>
+                  <a:srgbClr val="D8D3C4"/>
+                </a:solidFill>
+                <a:latin typeface="Be Vietnam Pro" pitchFamily="34" charset="0"/>
+                <a:ea typeface="Be Vietnam Pro" pitchFamily="34" charset="-122"/>
+                <a:cs typeface="Be Vietnam Pro" pitchFamily="34" charset="-120"/>
+              </a:rPr>
+              <a:t> hóa</a:t>
+            </a:r>
+            <a:r>
+              <a:rPr lang="en-US" sz="2100" dirty="0" spc="5" kern="0">
+                <a:solidFill>
+                  <a:srgbClr val="D8D3C4"/>
+                </a:solidFill>
+                <a:latin typeface="Be Vietnam Pro" pitchFamily="34" charset="0"/>
+                <a:ea typeface="Be Vietnam Pro" pitchFamily="34" charset="-122"/>
+                <a:cs typeface="Be Vietnam Pro" pitchFamily="34" charset="-120"/>
+              </a:rPr>
+              <a:t> (JWE),</a:t>
+            </a:r>
+            <a:r>
+              <a:rPr lang="en-US" sz="2100" dirty="0" spc="-8" kern="0">
+                <a:solidFill>
+                  <a:srgbClr val="D8D3C4"/>
+                </a:solidFill>
+                <a:latin typeface="Be Vietnam Pro" pitchFamily="34" charset="0"/>
+                <a:ea typeface="Be Vietnam Pro" pitchFamily="34" charset="-122"/>
+                <a:cs typeface="Be Vietnam Pro" pitchFamily="34" charset="-120"/>
+              </a:rPr>
+              <a:t> một</a:t>
+            </a:r>
+            <a:r>
+              <a:rPr lang="en-US" sz="2100" dirty="0" spc="-2" kern="0">
+                <a:solidFill>
+                  <a:srgbClr val="D8D3C4"/>
+                </a:solidFill>
+                <a:latin typeface="Be Vietnam Pro" pitchFamily="34" charset="0"/>
+                <a:ea typeface="Be Vietnam Pro" pitchFamily="34" charset="-122"/>
+                <a:cs typeface="Be Vietnam Pro" pitchFamily="34" charset="-120"/>
+              </a:rPr>
+              <a:t> dạng khác</a:t>
+            </a:r>
+            <a:r>
+              <a:rPr lang="en-US" sz="2100" dirty="0" spc="-3" kern="0">
+                <a:solidFill>
+                  <a:srgbClr val="D8D3C4"/>
+                </a:solidFill>
+                <a:latin typeface="Be Vietnam Pro" pitchFamily="34" charset="0"/>
+                <a:ea typeface="Be Vietnam Pro" pitchFamily="34" charset="-122"/>
+                <a:cs typeface="Be Vietnam Pro" pitchFamily="34" charset="-120"/>
+              </a:rPr>
+              <a:t> có</a:t>
+            </a:r>
+            <a:r>
+              <a:rPr lang="en-US" sz="2100" dirty="0" spc="-2" kern="0">
+                <a:solidFill>
+                  <a:srgbClr val="D8D3C4"/>
+                </a:solidFill>
+                <a:latin typeface="Be Vietnam Pro" pitchFamily="34" charset="0"/>
+                <a:ea typeface="Be Vietnam Pro" pitchFamily="34" charset="-122"/>
+                <a:cs typeface="Be Vietnam Pro" pitchFamily="34" charset="-120"/>
+              </a:rPr>
+              <a:t> cấu</a:t>
+            </a:r>
+            <a:r>
+              <a:rPr lang="en-US" sz="2100" dirty="0" spc="-1" kern="0">
+                <a:solidFill>
+                  <a:srgbClr val="D8D3C4"/>
+                </a:solidFill>
+                <a:latin typeface="Be Vietnam Pro" pitchFamily="34" charset="0"/>
+                <a:ea typeface="Be Vietnam Pro" pitchFamily="34" charset="-122"/>
+                <a:cs typeface="Be Vietnam Pro" pitchFamily="34" charset="-120"/>
+              </a:rPr>
+              <a:t> trúc khác,</a:t>
             </a:r>
             <a:r>
               <a:rPr lang="en-US" sz="2100" dirty="0" spc="-9" kern="0">
@@ -21561,7 +21773,7 @@
               <a:t> ngoài</a:t>
             </a:r>
             <a:r>
-              <a:rPr lang="en-US" sz="2100" dirty="0" spc="-3" kern="0">
+              <a:rPr lang="en-US" sz="2100" dirty="0" spc="-5" kern="0">
                 <a:solidFill>
                   <a:srgbClr val="D8D3C4"/>
                 </a:solidFill>
@@ -21569,32 +21781,10 @@
                 <a:ea typeface="Be Vietnam Pro" pitchFamily="34" charset="-122"/>
                 <a:cs typeface="Be Vietnam Pro" pitchFamily="34" charset="-120"/>
               </a:rPr>
-              <a:t> phạm</a:t>
-            </a:r>
-            <a:r>
-              <a:rPr lang="en-US" sz="2100" dirty="0" spc="0" kern="0">
-                <a:solidFill>
-                  <a:srgbClr val="D8D3C4"/>
-                </a:solidFill>
-                <a:latin typeface="Be Vietnam Pro" pitchFamily="34" charset="0"/>
-                <a:ea typeface="Be Vietnam Pro" pitchFamily="34" charset="-122"/>
-                <a:cs typeface="Be Vietnam Pro" pitchFamily="34" charset="-120"/>
-              </a:rPr>
-              <a:t> vi</a:t>
-            </a:r>
-            <a:r>
-              <a:rPr lang="en-US" sz="2100" dirty="0" spc="-5" kern="0">
-                <a:solidFill>
-                  <a:srgbClr val="D8D3C4"/>
-                </a:solidFill>
-                <a:latin typeface="Be Vietnam Pro" pitchFamily="34" charset="0"/>
-                <a:ea typeface="Be Vietnam Pro" pitchFamily="34" charset="-122"/>
-                <a:cs typeface="Be Vietnam Pro" pitchFamily="34" charset="-120"/>
-              </a:rPr>
               <a:t> bài</a:t>
             </a:r>
             <a:r>
-              <a:rPr lang="en-US" sz="2100" dirty="0" spc="-8" kern="0">
+              <a:rPr lang="en-US" sz="2100" dirty="0" spc="-7" kern="0">
                 <a:solidFill>
                   <a:srgbClr val="D8D3C4"/>
                 </a:solidFill>
@@ -21610,7 +21800,7 @@
       </p:sp>
       <p:sp>
         <p:nvSpPr>
-          <p:cNvPr id="28" name="Connector line-1792334537349-281426986"/>
+          <p:cNvPr id="28" name="Connector line-1792337919383-915587159"/>
           <p:cNvSpPr/>
           <p:nvPr/>
         </p:nvSpPr>

</xml_diff>

<commit_message>
System Design vi: sd-14-020 deck adds the expected-issuer check
Co-Authored-By: Claude Sonnet 5.5 <noreply@anthropic.com>
Claude-Session: https://claude.ai/code/session_01WnjciXNJBLEd8jy3HrG49S
</commit_message>
<xml_diff>
--- a/system-design-101/vi/lessons/sd-14-020/slides/sd-14-020.pptx
+++ b/system-design-101/vi/lessons/sd-14-020/slides/sd-14-020.pptx
@@ -18019,12 +18019,12 @@
         </p:nvSpPr>
         <p:spPr>
           <a:xfrm>
-            <a:off x="914400" y="3333750"/>
-            <a:ext cx="16459200" cy="1428750"/>
+            <a:off x="914400" y="3238500"/>
+            <a:ext cx="16459200" cy="1238250"/>
           </a:xfrm>
           <a:prstGeom prst="roundRect">
             <a:avLst>
-              <a:gd name="adj" fmla="val 17333"/>
+              <a:gd name="adj" fmla="val 20000"/>
             </a:avLst>
           </a:prstGeom>
           <a:solidFill>
@@ -18046,7 +18046,7 @@
         </p:nvSpPr>
         <p:spPr>
           <a:xfrm>
-            <a:off x="1162050" y="3724275"/>
+            <a:off x="1162050" y="3533775"/>
             <a:ext cx="647700" cy="647700"/>
           </a:xfrm>
           <a:prstGeom prst="ellipse">
@@ -18066,7 +18066,7 @@
         </p:nvSpPr>
         <p:spPr>
           <a:xfrm>
-            <a:off x="1200150" y="3819525"/>
+            <a:off x="1200150" y="3629025"/>
             <a:ext cx="571500" cy="457200"/>
           </a:xfrm>
           <a:prstGeom prst="rect">
@@ -18105,7 +18105,7 @@
         </p:nvSpPr>
         <p:spPr>
           <a:xfrm>
-            <a:off x="2190750" y="3619500"/>
+            <a:off x="2190750" y="3390900"/>
             <a:ext cx="7048500" cy="495300"/>
           </a:xfrm>
           <a:prstGeom prst="rect">
@@ -18199,7 +18199,7 @@
         </p:nvSpPr>
         <p:spPr>
           <a:xfrm>
-            <a:off x="2190750" y="4171950"/>
+            <a:off x="2190750" y="3943350"/>
             <a:ext cx="7048500" cy="381000"/>
           </a:xfrm>
           <a:prstGeom prst="rect">
@@ -18271,7 +18271,7 @@
         </p:nvSpPr>
         <p:spPr>
           <a:xfrm>
-            <a:off x="9525000" y="3790950"/>
+            <a:off x="9525000" y="3600450"/>
             <a:ext cx="2762250" cy="514350"/>
           </a:xfrm>
           <a:prstGeom prst="roundRect">
@@ -18325,7 +18325,7 @@
         </p:nvSpPr>
         <p:spPr>
           <a:xfrm>
-            <a:off x="12401550" y="4048125"/>
+            <a:off x="12401550" y="3857625"/>
             <a:ext cx="1104900" cy="0"/>
           </a:xfrm>
           <a:prstGeom prst="line">
@@ -18350,7 +18350,7 @@
         </p:nvSpPr>
         <p:spPr>
           <a:xfrm>
-            <a:off x="13620750" y="3790950"/>
+            <a:off x="13620750" y="3600450"/>
             <a:ext cx="3371850" cy="514350"/>
           </a:xfrm>
           <a:prstGeom prst="roundRect">
@@ -18398,12 +18398,12 @@
         </p:nvSpPr>
         <p:spPr>
           <a:xfrm>
-            <a:off x="914400" y="4953000"/>
-            <a:ext cx="16459200" cy="1428750"/>
+            <a:off x="914400" y="4629150"/>
+            <a:ext cx="16459200" cy="1238250"/>
           </a:xfrm>
           <a:prstGeom prst="roundRect">
             <a:avLst>
-              <a:gd name="adj" fmla="val 17333"/>
+              <a:gd name="adj" fmla="val 20000"/>
             </a:avLst>
           </a:prstGeom>
           <a:solidFill>
@@ -18425,7 +18425,7 @@
         </p:nvSpPr>
         <p:spPr>
           <a:xfrm>
-            <a:off x="1162050" y="5343525"/>
+            <a:off x="1162050" y="4924425"/>
             <a:ext cx="647700" cy="647700"/>
           </a:xfrm>
           <a:prstGeom prst="ellipse">
@@ -18445,7 +18445,7 @@
         </p:nvSpPr>
         <p:spPr>
           <a:xfrm>
-            <a:off x="1200150" y="5438775"/>
+            <a:off x="1200150" y="5019675"/>
             <a:ext cx="571500" cy="457200"/>
           </a:xfrm>
           <a:prstGeom prst="rect">
@@ -18484,7 +18484,7 @@
         </p:nvSpPr>
         <p:spPr>
           <a:xfrm>
-            <a:off x="2190750" y="5238750"/>
+            <a:off x="2190750" y="4781550"/>
             <a:ext cx="7048500" cy="495300"/>
           </a:xfrm>
           <a:prstGeom prst="rect">
@@ -18567,7 +18567,7 @@
         </p:nvSpPr>
         <p:spPr>
           <a:xfrm>
-            <a:off x="2190750" y="5791200"/>
+            <a:off x="2190750" y="5334000"/>
             <a:ext cx="7048500" cy="381000"/>
           </a:xfrm>
           <a:prstGeom prst="rect">
@@ -18628,7 +18628,7 @@
         </p:nvSpPr>
         <p:spPr>
           <a:xfrm>
-            <a:off x="9525000" y="5410200"/>
+            <a:off x="9525000" y="4991100"/>
             <a:ext cx="2762250" cy="514350"/>
           </a:xfrm>
           <a:prstGeom prst="roundRect">
@@ -18682,7 +18682,7 @@
         </p:nvSpPr>
         <p:spPr>
           <a:xfrm>
-            <a:off x="12401550" y="5667375"/>
+            <a:off x="12401550" y="5248275"/>
             <a:ext cx="1104900" cy="0"/>
           </a:xfrm>
           <a:prstGeom prst="line">
@@ -18707,7 +18707,7 @@
         </p:nvSpPr>
         <p:spPr>
           <a:xfrm>
-            <a:off x="13620750" y="5410200"/>
+            <a:off x="13620750" y="4991100"/>
             <a:ext cx="3371850" cy="514350"/>
           </a:xfrm>
           <a:prstGeom prst="roundRect">
@@ -18777,12 +18777,12 @@
         </p:nvSpPr>
         <p:spPr>
           <a:xfrm>
-            <a:off x="914400" y="6572250"/>
-            <a:ext cx="16459200" cy="2286000"/>
+            <a:off x="914400" y="6019800"/>
+            <a:ext cx="16459200" cy="2876550"/>
           </a:xfrm>
           <a:prstGeom prst="roundRect">
             <a:avLst>
-              <a:gd name="adj" fmla="val 10833"/>
+              <a:gd name="adj" fmla="val 8609"/>
             </a:avLst>
           </a:prstGeom>
           <a:solidFill>
@@ -18804,7 +18804,7 @@
         </p:nvSpPr>
         <p:spPr>
           <a:xfrm>
-            <a:off x="1162050" y="7391400"/>
+            <a:off x="1162050" y="7134225"/>
             <a:ext cx="647700" cy="647700"/>
           </a:xfrm>
           <a:prstGeom prst="ellipse">
@@ -18824,7 +18824,7 @@
         </p:nvSpPr>
         <p:spPr>
           <a:xfrm>
-            <a:off x="1200150" y="7486650"/>
+            <a:off x="1200150" y="7229475"/>
             <a:ext cx="571500" cy="457200"/>
           </a:xfrm>
           <a:prstGeom prst="rect">
@@ -18863,7 +18863,7 @@
         </p:nvSpPr>
         <p:spPr>
           <a:xfrm>
-            <a:off x="2190750" y="7048500"/>
+            <a:off x="2190750" y="6600825"/>
             <a:ext cx="7048500" cy="495300"/>
           </a:xfrm>
           <a:prstGeom prst="rect">
@@ -18946,7 +18946,7 @@
         </p:nvSpPr>
         <p:spPr>
           <a:xfrm>
-            <a:off x="2190750" y="7600950"/>
+            <a:off x="2190750" y="7153275"/>
             <a:ext cx="7048500" cy="381000"/>
           </a:xfrm>
           <a:prstGeom prst="rect">
@@ -18963,7 +18963,7 @@
               <a:buNone/>
             </a:pPr>
             <a:r>
-              <a:rPr lang="en-US" sz="2100" dirty="0" spc="3" kern="0">
+              <a:rPr lang="en-US" sz="2100" dirty="0" spc="-2" kern="0">
                 <a:solidFill>
                   <a:srgbClr val="6B6A66"/>
                 </a:solidFill>
@@ -18971,7 +18971,51 @@
                 <a:ea typeface="Be Vietnam Pro" pitchFamily="34" charset="-122"/>
                 <a:cs typeface="Be Vietnam Pro" pitchFamily="34" charset="-120"/>
               </a:rPr>
-              <a:t>kiểm</a:t>
+              <a:t>aud,</a:t>
+            </a:r>
+            <a:r>
+              <a:rPr lang="en-US" sz="2100" dirty="0" spc="2" kern="0">
+                <a:solidFill>
+                  <a:srgbClr val="6B6A66"/>
+                </a:solidFill>
+                <a:latin typeface="Be Vietnam Pro" pitchFamily="34" charset="0"/>
+                <a:ea typeface="Be Vietnam Pro" pitchFamily="34" charset="-122"/>
+                <a:cs typeface="Be Vietnam Pro" pitchFamily="34" charset="-120"/>
+              </a:rPr>
+              <a:t> iss</a:t>
+            </a:r>
+            <a:r>
+              <a:rPr lang="en-US" sz="2100" dirty="0" spc="0" kern="0">
+                <a:solidFill>
+                  <a:srgbClr val="6B6A66"/>
+                </a:solidFill>
+                <a:latin typeface="Be Vietnam Pro" pitchFamily="34" charset="0"/>
+                <a:ea typeface="Be Vietnam Pro" pitchFamily="34" charset="-122"/>
+                <a:cs typeface="Be Vietnam Pro" pitchFamily="34" charset="-120"/>
+              </a:rPr>
+              <a:t> chỉ</a:t>
+            </a:r>
+            <a:r>
+              <a:rPr lang="en-US" sz="2100" dirty="0" spc="1" kern="0">
+                <a:solidFill>
+                  <a:srgbClr val="6B6A66"/>
+                </a:solidFill>
+                <a:latin typeface="Be Vietnam Pro" pitchFamily="34" charset="0"/>
+                <a:ea typeface="Be Vietnam Pro" pitchFamily="34" charset="-122"/>
+                <a:cs typeface="Be Vietnam Pro" pitchFamily="34" charset="-120"/>
+              </a:rPr>
+              <a:t> kiểm khi nêu</a:t>
+            </a:r>
+            <a:r>
+              <a:rPr lang="en-US" sz="2100" dirty="0" spc="-3" kern="0">
+                <a:solidFill>
+                  <a:srgbClr val="6B6A66"/>
+                </a:solidFill>
+                <a:latin typeface="Be Vietnam Pro" pitchFamily="34" charset="0"/>
+                <a:ea typeface="Be Vietnam Pro" pitchFamily="34" charset="-122"/>
+                <a:cs typeface="Be Vietnam Pro" pitchFamily="34" charset="-120"/>
+              </a:rPr>
+              <a:t> bên</a:t>
             </a:r>
             <a:r>
               <a:rPr lang="en-US" sz="2100" dirty="0" spc="-1" kern="0">
@@ -18982,10 +19026,10 @@
                 <a:ea typeface="Be Vietnam Pro" pitchFamily="34" charset="-122"/>
                 <a:cs typeface="Be Vietnam Pro" pitchFamily="34" charset="-120"/>
               </a:rPr>
-              <a:t> tiếp</a:t>
-            </a:r>
-            <a:r>
-              <a:rPr lang="en-US" sz="2100" dirty="0" spc="-16" kern="0">
+              <a:t> mong</a:t>
+            </a:r>
+            <a:r>
+              <a:rPr lang="en-US" sz="2100" dirty="0" spc="10" kern="0">
                 <a:solidFill>
                   <a:srgbClr val="6B6A66"/>
                 </a:solidFill>
@@ -18993,18 +19037,7 @@
                 <a:ea typeface="Be Vietnam Pro" pitchFamily="34" charset="-122"/>
                 <a:cs typeface="Be Vietnam Pro" pitchFamily="34" charset="-120"/>
               </a:rPr>
-              <a:t> exp,</a:t>
-            </a:r>
-            <a:r>
-              <a:rPr lang="en-US" sz="2100" dirty="0" spc="-2" kern="0">
-                <a:solidFill>
-                  <a:srgbClr val="6B6A66"/>
-                </a:solidFill>
-                <a:latin typeface="Be Vietnam Pro" pitchFamily="34" charset="0"/>
-                <a:ea typeface="Be Vietnam Pro" pitchFamily="34" charset="-122"/>
-                <a:cs typeface="Be Vietnam Pro" pitchFamily="34" charset="-120"/>
-              </a:rPr>
-              <a:t> nbf, aud</a:t>
+              <a:t> đợi</a:t>
             </a:r>
             <a:endParaRPr lang="en-US" sz="2100" dirty="0"/>
           </a:p>
@@ -19018,7 +19051,7 @@
         </p:nvSpPr>
         <p:spPr>
           <a:xfrm>
-            <a:off x="2190750" y="8077200"/>
+            <a:off x="2190750" y="7991475"/>
             <a:ext cx="7048500" cy="323850"/>
           </a:xfrm>
           <a:prstGeom prst="rect">
@@ -19156,7 +19189,7 @@
         </p:nvSpPr>
         <p:spPr>
           <a:xfrm>
-            <a:off x="9525000" y="6819900"/>
+            <a:off x="9525000" y="6229350"/>
             <a:ext cx="2762250" cy="514350"/>
           </a:xfrm>
           <a:prstGeom prst="roundRect">
@@ -19221,7 +19254,7 @@
         </p:nvSpPr>
         <p:spPr>
           <a:xfrm>
-            <a:off x="12401550" y="7077075"/>
+            <a:off x="12401550" y="6486525"/>
             <a:ext cx="1104900" cy="0"/>
           </a:xfrm>
           <a:prstGeom prst="line">
@@ -19246,7 +19279,7 @@
         </p:nvSpPr>
         <p:spPr>
           <a:xfrm>
-            <a:off x="13620750" y="6819900"/>
+            <a:off x="13620750" y="6229350"/>
             <a:ext cx="3371850" cy="514350"/>
           </a:xfrm>
           <a:prstGeom prst="roundRect">
@@ -19294,7 +19327,7 @@
         </p:nvSpPr>
         <p:spPr>
           <a:xfrm>
-            <a:off x="9525000" y="7505700"/>
+            <a:off x="9525000" y="6877050"/>
             <a:ext cx="2762250" cy="514350"/>
           </a:xfrm>
           <a:prstGeom prst="roundRect">
@@ -19370,7 +19403,7 @@
         </p:nvSpPr>
         <p:spPr>
           <a:xfrm>
-            <a:off x="12401550" y="7762875"/>
+            <a:off x="12401550" y="7134225"/>
             <a:ext cx="1104900" cy="0"/>
           </a:xfrm>
           <a:prstGeom prst="line">
@@ -19395,7 +19428,7 @@
         </p:nvSpPr>
         <p:spPr>
           <a:xfrm>
-            <a:off x="13620750" y="7505700"/>
+            <a:off x="13620750" y="6877050"/>
             <a:ext cx="3371850" cy="514350"/>
           </a:xfrm>
           <a:prstGeom prst="roundRect">
@@ -19443,7 +19476,7 @@
         </p:nvSpPr>
         <p:spPr>
           <a:xfrm>
-            <a:off x="9525000" y="8191500"/>
+            <a:off x="9525000" y="7524750"/>
             <a:ext cx="2762250" cy="514350"/>
           </a:xfrm>
           <a:prstGeom prst="roundRect">
@@ -19508,7 +19541,7 @@
         </p:nvSpPr>
         <p:spPr>
           <a:xfrm>
-            <a:off x="12401550" y="8448675"/>
+            <a:off x="12401550" y="7781925"/>
             <a:ext cx="1104900" cy="0"/>
           </a:xfrm>
           <a:prstGeom prst="line">
@@ -19533,7 +19566,7 @@
         </p:nvSpPr>
         <p:spPr>
           <a:xfrm>
-            <a:off x="13620750" y="8191500"/>
+            <a:off x="13620750" y="7524750"/>
             <a:ext cx="3371850" cy="514350"/>
           </a:xfrm>
           <a:prstGeom prst="roundRect">
@@ -19933,7 +19966,261 @@
       </p:sp>
       <p:sp>
         <p:nvSpPr>
-          <p:cNvPr id="48" name="Shape 46"/>
+          <p:cNvPr id="48" name="Text 46"/>
+          <p:cNvSpPr/>
+          <p:nvPr/>
+        </p:nvSpPr>
+        <p:spPr>
+          <a:xfrm>
+            <a:off x="2190750" y="7629525"/>
+            <a:ext cx="7048500" cy="323850"/>
+          </a:xfrm>
+          <a:prstGeom prst="rect">
+            <a:avLst/>
+          </a:prstGeom>
+          <a:noFill/>
+          <a:ln/>
+        </p:spPr>
+        <p:txBody>
+          <a:bodyPr wrap="square" lIns="0" tIns="0" rIns="0" bIns="0" rtlCol="0" anchor="ctr"/>
+          <a:lstStyle/>
+          <a:p>
+            <a:pPr algn="l" indent="0" marL="0">
+              <a:buNone/>
+            </a:pPr>
+            <a:r>
+              <a:rPr lang="en-US" sz="1800" dirty="0" spc="-3" kern="0">
+                <a:solidFill>
+                  <a:srgbClr val="6B6A66"/>
+                </a:solidFill>
+                <a:latin typeface="Be Vietnam Pro" pitchFamily="34" charset="0"/>
+                <a:ea typeface="Be Vietnam Pro" pitchFamily="34" charset="-122"/>
+                <a:cs typeface="Be Vietnam Pro" pitchFamily="34" charset="-120"/>
+              </a:rPr>
+              <a:t>Không</a:t>
+            </a:r>
+            <a:r>
+              <a:rPr lang="en-US" sz="1800" dirty="0" spc="-4" kern="0">
+                <a:solidFill>
+                  <a:srgbClr val="6B6A66"/>
+                </a:solidFill>
+                <a:latin typeface="Be Vietnam Pro" pitchFamily="34" charset="0"/>
+                <a:ea typeface="Be Vietnam Pro" pitchFamily="34" charset="-122"/>
+                <a:cs typeface="Be Vietnam Pro" pitchFamily="34" charset="-120"/>
+              </a:rPr>
+              <a:t> nêu</a:t>
+            </a:r>
+            <a:r>
+              <a:rPr lang="en-US" sz="1800" dirty="0" spc="1" kern="0">
+                <a:solidFill>
+                  <a:srgbClr val="6B6A66"/>
+                </a:solidFill>
+                <a:latin typeface="Be Vietnam Pro" pitchFamily="34" charset="0"/>
+                <a:ea typeface="Be Vietnam Pro" pitchFamily="34" charset="-122"/>
+                <a:cs typeface="Be Vietnam Pro" pitchFamily="34" charset="-120"/>
+              </a:rPr>
+              <a:t> iss</a:t>
+            </a:r>
+            <a:r>
+              <a:rPr lang="en-US" sz="1800" dirty="0" spc="-1" kern="0">
+                <a:solidFill>
+                  <a:srgbClr val="6B6A66"/>
+                </a:solidFill>
+                <a:latin typeface="Be Vietnam Pro" pitchFamily="34" charset="0"/>
+                <a:ea typeface="Be Vietnam Pro" pitchFamily="34" charset="-122"/>
+                <a:cs typeface="Be Vietnam Pro" pitchFamily="34" charset="-120"/>
+              </a:rPr>
+              <a:t> thì</a:t>
+            </a:r>
+            <a:r>
+              <a:rPr lang="en-US" sz="1800" dirty="0" spc="1" kern="0">
+                <a:solidFill>
+                  <a:srgbClr val="6B6A66"/>
+                </a:solidFill>
+                <a:latin typeface="Be Vietnam Pro" pitchFamily="34" charset="0"/>
+                <a:ea typeface="Be Vietnam Pro" pitchFamily="34" charset="-122"/>
+                <a:cs typeface="Be Vietnam Pro" pitchFamily="34" charset="-120"/>
+              </a:rPr>
+              <a:t> iss</a:t>
+            </a:r>
+            <a:r>
+              <a:rPr lang="en-US" sz="1800" dirty="0" spc="0" kern="0">
+                <a:solidFill>
+                  <a:srgbClr val="6B6A66"/>
+                </a:solidFill>
+                <a:latin typeface="Be Vietnam Pro" pitchFamily="34" charset="0"/>
+                <a:ea typeface="Be Vietnam Pro" pitchFamily="34" charset="-122"/>
+                <a:cs typeface="Be Vietnam Pro" pitchFamily="34" charset="-120"/>
+              </a:rPr>
+              <a:t> nào</a:t>
+            </a:r>
+            <a:r>
+              <a:rPr lang="en-US" sz="1800" dirty="0" spc="-1" kern="0">
+                <a:solidFill>
+                  <a:srgbClr val="6B6A66"/>
+                </a:solidFill>
+                <a:latin typeface="Be Vietnam Pro" pitchFamily="34" charset="0"/>
+                <a:ea typeface="Be Vietnam Pro" pitchFamily="34" charset="-122"/>
+                <a:cs typeface="Be Vietnam Pro" pitchFamily="34" charset="-120"/>
+              </a:rPr>
+              <a:t> cũng</a:t>
+            </a:r>
+            <a:r>
+              <a:rPr lang="en-US" sz="1800" dirty="0" spc="1" kern="0">
+                <a:solidFill>
+                  <a:srgbClr val="6B6A66"/>
+                </a:solidFill>
+                <a:latin typeface="Be Vietnam Pro" pitchFamily="34" charset="0"/>
+                <a:ea typeface="Be Vietnam Pro" pitchFamily="34" charset="-122"/>
+                <a:cs typeface="Be Vietnam Pro" pitchFamily="34" charset="-120"/>
+              </a:rPr>
+              <a:t> qua.</a:t>
+            </a:r>
+            <a:endParaRPr lang="en-US" sz="1800" dirty="0"/>
+          </a:p>
+        </p:txBody>
+      </p:sp>
+      <p:sp>
+        <p:nvSpPr>
+          <p:cNvPr id="49" name="Text 47"/>
+          <p:cNvSpPr/>
+          <p:nvPr/>
+        </p:nvSpPr>
+        <p:spPr>
+          <a:xfrm>
+            <a:off x="9525000" y="8172450"/>
+            <a:ext cx="2762250" cy="514350"/>
+          </a:xfrm>
+          <a:prstGeom prst="roundRect">
+            <a:avLst>
+              <a:gd name="adj" fmla="val 50000"/>
+            </a:avLst>
+          </a:prstGeom>
+          <a:solidFill>
+            <a:srgbClr val="14161C"/>
+          </a:solidFill>
+          <a:ln/>
+        </p:spPr>
+        <p:txBody>
+          <a:bodyPr wrap="square" lIns="0" tIns="0" rIns="0" bIns="0" rtlCol="0" anchor="ctr"/>
+          <a:lstStyle/>
+          <a:p>
+            <a:pPr algn="ctr" indent="0" marL="0">
+              <a:buNone/>
+            </a:pPr>
+            <a:r>
+              <a:rPr lang="en-US" sz="1950" dirty="0" spc="1" kern="0">
+                <a:solidFill>
+                  <a:srgbClr val="F3EEE3"/>
+                </a:solidFill>
+                <a:latin typeface="Be Vietnam Pro SemiBold" pitchFamily="34" charset="0"/>
+                <a:ea typeface="Be Vietnam Pro SemiBold" pitchFamily="34" charset="-122"/>
+                <a:cs typeface="Be Vietnam Pro SemiBold" pitchFamily="34" charset="-120"/>
+              </a:rPr>
+              <a:t>iss</a:t>
+            </a:r>
+            <a:r>
+              <a:rPr lang="en-US" sz="1950" dirty="0" spc="-4" kern="0">
+                <a:solidFill>
+                  <a:srgbClr val="F3EEE3"/>
+                </a:solidFill>
+                <a:latin typeface="Be Vietnam Pro SemiBold" pitchFamily="34" charset="0"/>
+                <a:ea typeface="Be Vietnam Pro SemiBold" pitchFamily="34" charset="-122"/>
+                <a:cs typeface="Be Vietnam Pro SemiBold" pitchFamily="34" charset="-120"/>
+              </a:rPr>
+              <a:t> không</a:t>
+            </a:r>
+            <a:r>
+              <a:rPr lang="en-US" sz="1950" dirty="0" spc="-1" kern="0">
+                <a:solidFill>
+                  <a:srgbClr val="F3EEE3"/>
+                </a:solidFill>
+                <a:latin typeface="Be Vietnam Pro SemiBold" pitchFamily="34" charset="0"/>
+                <a:ea typeface="Be Vietnam Pro SemiBold" pitchFamily="34" charset="-122"/>
+                <a:cs typeface="Be Vietnam Pro SemiBold" pitchFamily="34" charset="-120"/>
+              </a:rPr>
+              <a:t> khớp</a:t>
+            </a:r>
+            <a:endParaRPr lang="en-US" sz="1950" dirty="0"/>
+          </a:p>
+        </p:txBody>
+      </p:sp>
+      <p:sp>
+        <p:nvSpPr>
+          <p:cNvPr id="50" name="Connector line-1792381647150-636886181"/>
+          <p:cNvSpPr/>
+          <p:nvPr/>
+        </p:nvSpPr>
+        <p:spPr>
+          <a:xfrm>
+            <a:off x="12401550" y="8429625"/>
+            <a:ext cx="1104900" cy="0"/>
+          </a:xfrm>
+          <a:prstGeom prst="line">
+            <a:avLst/>
+          </a:prstGeom>
+          <a:noFill/>
+          <a:ln w="38100">
+            <a:solidFill>
+              <a:srgbClr val="14161C"/>
+            </a:solidFill>
+            <a:prstDash val="solid"/>
+            <a:headEnd type="none"/>
+            <a:tailEnd type="triangle" w="lg" len="lg"/>
+          </a:ln>
+        </p:spPr>
+      </p:sp>
+      <p:sp>
+        <p:nvSpPr>
+          <p:cNvPr id="51" name="Text 49"/>
+          <p:cNvSpPr/>
+          <p:nvPr/>
+        </p:nvSpPr>
+        <p:spPr>
+          <a:xfrm>
+            <a:off x="13620750" y="8172450"/>
+            <a:ext cx="3371850" cy="514350"/>
+          </a:xfrm>
+          <a:prstGeom prst="roundRect">
+            <a:avLst>
+              <a:gd name="adj" fmla="val 50000"/>
+            </a:avLst>
+          </a:prstGeom>
+          <a:solidFill>
+            <a:srgbClr val="F8D9D0"/>
+          </a:solidFill>
+          <a:ln w="19050">
+            <a:solidFill>
+              <a:srgbClr val="E8472B"/>
+            </a:solidFill>
+            <a:prstDash val="solid"/>
+          </a:ln>
+        </p:spPr>
+        <p:txBody>
+          <a:bodyPr wrap="square" lIns="0" tIns="0" rIns="0" bIns="0" rtlCol="0" anchor="ctr"/>
+          <a:lstStyle/>
+          <a:p>
+            <a:pPr algn="ctr" indent="0" marL="0">
+              <a:buNone/>
+            </a:pPr>
+            <a:r>
+              <a:rPr lang="en-US" sz="1800" b="1" dirty="0" spc="-8" kern="0">
+                <a:solidFill>
+                  <a:srgbClr val="E8472B"/>
+                </a:solidFill>
+                <a:latin typeface="Be Vietnam Pro" pitchFamily="34" charset="0"/>
+                <a:ea typeface="Be Vietnam Pro" pitchFamily="34" charset="-122"/>
+                <a:cs typeface="Be Vietnam Pro" pitchFamily="34" charset="-120"/>
+              </a:rPr>
+              <a:t>InvalidIssuerError</a:t>
+            </a:r>
+            <a:endParaRPr lang="en-US" sz="1800" dirty="0"/>
+          </a:p>
+        </p:txBody>
+      </p:sp>
+      <p:sp>
+        <p:nvSpPr>
+          <p:cNvPr id="52" name="Shape 50"/>
           <p:cNvSpPr/>
           <p:nvPr/>
         </p:nvSpPr>
@@ -19957,7 +20244,7 @@
       </p:sp>
       <p:pic>
         <p:nvPicPr>
-          <p:cNvPr id="49" name="Moda image moda-export-watermark-33af6f5c-62d3-4f33-ba49-f0e84264d57e" descr="">    </p:cNvPr>
+          <p:cNvPr id="53" name="Moda image moda-export-watermark-33af6f5c-62d3-4f33-ba49-f0e84264d57e" descr="">    </p:cNvPr>
           <p:cNvPicPr>
             <a:picLocks noChangeAspect="1"/>
           </p:cNvPicPr>

</xml_diff>

<commit_message>
System Design vi: sd-14-020 deck states the audience and issuer defaults correctly
Co-Authored-By: Claude Sonnet 5.5 <noreply@anthropic.com>
Claude-Session: https://claude.ai/code/session_01WnjciXNJBLEd8jy3HrG49S
</commit_message>
<xml_diff>
--- a/system-design-101/vi/lessons/sd-14-020/slides/sd-14-020.pptx
+++ b/system-design-101/vi/lessons/sd-14-020/slides/sd-14-020.pptx
@@ -18963,6 +18963,61 @@
               <a:buNone/>
             </a:pPr>
             <a:r>
+              <a:rPr lang="en-US" sz="2100" dirty="0" spc="0" kern="0">
+                <a:solidFill>
+                  <a:srgbClr val="6B6A66"/>
+                </a:solidFill>
+                <a:latin typeface="Be Vietnam Pro" pitchFamily="34" charset="0"/>
+                <a:ea typeface="Be Vietnam Pro" pitchFamily="34" charset="-122"/>
+                <a:cs typeface="Be Vietnam Pro" pitchFamily="34" charset="-120"/>
+              </a:rPr>
+              <a:t>Mặc</a:t>
+            </a:r>
+            <a:r>
+              <a:rPr lang="en-US" sz="2100" dirty="0" spc="18" kern="0">
+                <a:solidFill>
+                  <a:srgbClr val="6B6A66"/>
+                </a:solidFill>
+                <a:latin typeface="Be Vietnam Pro" pitchFamily="34" charset="0"/>
+                <a:ea typeface="Be Vietnam Pro" pitchFamily="34" charset="-122"/>
+                <a:cs typeface="Be Vietnam Pro" pitchFamily="34" charset="-120"/>
+              </a:rPr>
+              <a:t> định</a:t>
+            </a:r>
+            <a:r>
+              <a:rPr lang="en-US" sz="2100" dirty="0" spc="-1" kern="0">
+                <a:solidFill>
+                  <a:srgbClr val="6B6A66"/>
+                </a:solidFill>
+                <a:latin typeface="Be Vietnam Pro" pitchFamily="34" charset="0"/>
+                <a:ea typeface="Be Vietnam Pro" pitchFamily="34" charset="-122"/>
+                <a:cs typeface="Be Vietnam Pro" pitchFamily="34" charset="-120"/>
+              </a:rPr>
+              <a:t> khác nhau:</a:t>
+            </a:r>
+            <a:r>
+              <a:rPr lang="en-US" sz="2100" dirty="0" spc="-3" kern="0">
+                <a:solidFill>
+                  <a:srgbClr val="6B6A66"/>
+                </a:solidFill>
+                <a:latin typeface="Be Vietnam Pro" pitchFamily="34" charset="0"/>
+                <a:ea typeface="Be Vietnam Pro" pitchFamily="34" charset="-122"/>
+                <a:cs typeface="Be Vietnam Pro" pitchFamily="34" charset="-120"/>
+              </a:rPr>
+              <a:t> có aud</a:t>
+            </a:r>
+            <a:r>
+              <a:rPr lang="en-US" sz="2100" dirty="0" spc="0" kern="0">
+                <a:solidFill>
+                  <a:srgbClr val="6B6A66"/>
+                </a:solidFill>
+                <a:latin typeface="Be Vietnam Pro" pitchFamily="34" charset="0"/>
+                <a:ea typeface="Be Vietnam Pro" pitchFamily="34" charset="-122"/>
+                <a:cs typeface="Be Vietnam Pro" pitchFamily="34" charset="-120"/>
+              </a:rPr>
+              <a:t> thì</a:t>
+            </a:r>
+            <a:r>
               <a:rPr lang="en-US" sz="2100" dirty="0" spc="-2" kern="0">
                 <a:solidFill>
                   <a:srgbClr val="6B6A66"/>
@@ -18971,10 +19026,10 @@
                 <a:ea typeface="Be Vietnam Pro" pitchFamily="34" charset="-122"/>
                 <a:cs typeface="Be Vietnam Pro" pitchFamily="34" charset="-120"/>
               </a:rPr>
-              <a:t>aud,</a:t>
-            </a:r>
-            <a:r>
-              <a:rPr lang="en-US" sz="2100" dirty="0" spc="2" kern="0">
+              <a:t> luôn</a:t>
+            </a:r>
+            <a:r>
+              <a:rPr lang="en-US" sz="2100" dirty="0" spc="-1" kern="0">
                 <a:solidFill>
                   <a:srgbClr val="6B6A66"/>
                 </a:solidFill>
@@ -18982,10 +19037,10 @@
                 <a:ea typeface="Be Vietnam Pro" pitchFamily="34" charset="-122"/>
                 <a:cs typeface="Be Vietnam Pro" pitchFamily="34" charset="-120"/>
               </a:rPr>
-              <a:t> iss</a:t>
-            </a:r>
-            <a:r>
-              <a:rPr lang="en-US" sz="2100" dirty="0" spc="0" kern="0">
+              <a:t> bị</a:t>
+            </a:r>
+            <a:r>
+              <a:rPr lang="en-US" sz="2100" dirty="0" spc="1" kern="0">
                 <a:solidFill>
                   <a:srgbClr val="6B6A66"/>
                 </a:solidFill>
@@ -18993,51 +19048,7 @@
                 <a:ea typeface="Be Vietnam Pro" pitchFamily="34" charset="-122"/>
                 <a:cs typeface="Be Vietnam Pro" pitchFamily="34" charset="-120"/>
               </a:rPr>
-              <a:t> chỉ</a:t>
-            </a:r>
-            <a:r>
-              <a:rPr lang="en-US" sz="2100" dirty="0" spc="1" kern="0">
-                <a:solidFill>
-                  <a:srgbClr val="6B6A66"/>
-                </a:solidFill>
-                <a:latin typeface="Be Vietnam Pro" pitchFamily="34" charset="0"/>
-                <a:ea typeface="Be Vietnam Pro" pitchFamily="34" charset="-122"/>
-                <a:cs typeface="Be Vietnam Pro" pitchFamily="34" charset="-120"/>
-              </a:rPr>
-              <a:t> kiểm khi nêu</a:t>
-            </a:r>
-            <a:r>
-              <a:rPr lang="en-US" sz="2100" dirty="0" spc="-3" kern="0">
-                <a:solidFill>
-                  <a:srgbClr val="6B6A66"/>
-                </a:solidFill>
-                <a:latin typeface="Be Vietnam Pro" pitchFamily="34" charset="0"/>
-                <a:ea typeface="Be Vietnam Pro" pitchFamily="34" charset="-122"/>
-                <a:cs typeface="Be Vietnam Pro" pitchFamily="34" charset="-120"/>
-              </a:rPr>
-              <a:t> bên</a:t>
-            </a:r>
-            <a:r>
-              <a:rPr lang="en-US" sz="2100" dirty="0" spc="-1" kern="0">
-                <a:solidFill>
-                  <a:srgbClr val="6B6A66"/>
-                </a:solidFill>
-                <a:latin typeface="Be Vietnam Pro" pitchFamily="34" charset="0"/>
-                <a:ea typeface="Be Vietnam Pro" pitchFamily="34" charset="-122"/>
-                <a:cs typeface="Be Vietnam Pro" pitchFamily="34" charset="-120"/>
-              </a:rPr>
-              <a:t> mong</a:t>
-            </a:r>
-            <a:r>
-              <a:rPr lang="en-US" sz="2100" dirty="0" spc="10" kern="0">
-                <a:solidFill>
-                  <a:srgbClr val="6B6A66"/>
-                </a:solidFill>
-                <a:latin typeface="Be Vietnam Pro" pitchFamily="34" charset="0"/>
-                <a:ea typeface="Be Vietnam Pro" pitchFamily="34" charset="-122"/>
-                <a:cs typeface="Be Vietnam Pro" pitchFamily="34" charset="-120"/>
-              </a:rPr>
-              <a:t> đợi</a:t>
+              <a:t> kiểm</a:t>
             </a:r>
             <a:endParaRPr lang="en-US" sz="2100" dirty="0"/>
           </a:p>

</xml_diff>